<commit_message>
Polish WPS deck slide titles
</commit_message>
<xml_diff>
--- a/docs/zh/00-代码总览与运行时走读-WPS兼容版.pptx
+++ b/docs/zh/00-代码总览与运行时走读-WPS兼容版.pptx
@@ -5995,7 +5995,7 @@
                 </a:solidFill>
                 <a:latin typeface="Arial"/>
               </a:rPr>
-              <a:t>文档里最重要的一组判断：状态载体分层</a:t>
+              <a:t>运行时状态载体</a:t>
             </a:r>
           </a:p>
         </p:txBody>
@@ -6308,7 +6308,7 @@
                 </a:solidFill>
                 <a:latin typeface="Arial"/>
               </a:rPr>
-              <a:t>文档里的另一个高价值产出：调试入口</a:t>
+              <a:t>调试与排障入口</a:t>
             </a:r>
           </a:p>
         </p:txBody>
@@ -6621,7 +6621,7 @@
                 </a:solidFill>
                 <a:latin typeface="Arial"/>
               </a:rPr>
-              <a:t>为什么它更像产品化 runtime</a:t>
+              <a:t>产品化 runtime 的控制面</a:t>
             </a:r>
           </a:p>
         </p:txBody>
@@ -6950,7 +6950,7 @@
                 </a:solidFill>
                 <a:latin typeface="Arial"/>
               </a:rPr>
-              <a:t>代码质量判断也需要进 PPT</a:t>
+              <a:t>代码质量与结构问题</a:t>
             </a:r>
           </a:p>
         </p:txBody>
@@ -7501,7 +7501,7 @@
                 </a:solidFill>
                 <a:latin typeface="Arial"/>
               </a:rPr>
-              <a:t>最后只保留最重要的结论</a:t>
+              <a:t>关键结论与阅读建议</a:t>
             </a:r>
           </a:p>
         </p:txBody>

</xml_diff>